<commit_message>
reordered some slides in lec-6
</commit_message>
<xml_diff>
--- a/Lec-6.pptx
+++ b/Lec-6.pptx
@@ -21,8 +21,8 @@
     <p:sldId id="342" r:id="rId12"/>
     <p:sldId id="386" r:id="rId13"/>
     <p:sldId id="343" r:id="rId14"/>
-    <p:sldId id="344" r:id="rId15"/>
-    <p:sldId id="345" r:id="rId16"/>
+    <p:sldId id="345" r:id="rId15"/>
+    <p:sldId id="344" r:id="rId16"/>
     <p:sldId id="346" r:id="rId17"/>
     <p:sldId id="347" r:id="rId18"/>
   </p:sldIdLst>
@@ -306,7 +306,7 @@
               <a:pPr>
                 <a:defRPr/>
               </a:pPr>
-              <a:t>8/8/2026</a:t>
+              <a:t>8/16/2026</a:t>
             </a:fld>
             <a:endParaRPr lang="en-US"/>
           </a:p>
@@ -8044,6 +8044,938 @@
       </p:grpSpPr>
       <p:sp>
         <p:nvSpPr>
+          <p:cNvPr id="3" name="Content Placeholder 2">
+            <a:extLst>
+              <a:ext uri="{FF2B5EF4-FFF2-40B4-BE49-F238E27FC236}">
+                <a16:creationId xmlns:a16="http://schemas.microsoft.com/office/drawing/2014/main" id="{860A1932-3B1E-BD8F-E960-6C9D68A298AD}"/>
+              </a:ext>
+            </a:extLst>
+          </p:cNvPr>
+          <p:cNvSpPr>
+            <a:spLocks noGrp="1"/>
+          </p:cNvSpPr>
+          <p:nvPr>
+            <p:ph sz="quarter" idx="10"/>
+          </p:nvPr>
+        </p:nvSpPr>
+        <p:spPr/>
+        <p:txBody>
+          <a:bodyPr/>
+          <a:lstStyle/>
+          <a:p>
+            <a:r>
+              <a:rPr lang="en-US" dirty="0">
+                <a:solidFill>
+                  <a:srgbClr val="C00000"/>
+                </a:solidFill>
+              </a:rPr>
+              <a:t>What does this circuit do?</a:t>
+            </a:r>
+            <a:endParaRPr lang="en-IN" dirty="0">
+              <a:solidFill>
+                <a:srgbClr val="C00000"/>
+              </a:solidFill>
+            </a:endParaRPr>
+          </a:p>
+        </p:txBody>
+      </p:sp>
+      <p:pic>
+        <p:nvPicPr>
+          <p:cNvPr id="4" name="Content Placeholder 3">
+            <a:extLst>
+              <a:ext uri="{FF2B5EF4-FFF2-40B4-BE49-F238E27FC236}">
+                <a16:creationId xmlns:a16="http://schemas.microsoft.com/office/drawing/2014/main" id="{A4EDC30D-0116-E52F-B455-4CF64FC8EE64}"/>
+              </a:ext>
+            </a:extLst>
+          </p:cNvPr>
+          <p:cNvPicPr>
+            <a:picLocks noGrp="1" noChangeAspect="1" noChangeArrowheads="1"/>
+          </p:cNvPicPr>
+          <p:nvPr>
+            <p:ph idx="1"/>
+          </p:nvPr>
+        </p:nvPicPr>
+        <p:blipFill>
+          <a:blip r:embed="rId2">
+            <a:extLst>
+              <a:ext uri="{28A0092B-C50C-407E-A947-70E740481C1C}">
+                <a14:useLocalDpi xmlns:a14="http://schemas.microsoft.com/office/drawing/2010/main" val="0"/>
+              </a:ext>
+            </a:extLst>
+          </a:blip>
+          <a:srcRect l="33333" t="48148" r="19444" b="18518"/>
+          <a:stretch>
+            <a:fillRect/>
+          </a:stretch>
+        </p:blipFill>
+        <p:spPr bwMode="auto">
+          <a:xfrm>
+            <a:off x="76201" y="1524001"/>
+            <a:ext cx="5613380" cy="2971800"/>
+          </a:xfrm>
+          <a:prstGeom prst="rect">
+            <a:avLst/>
+          </a:prstGeom>
+          <a:noFill/>
+          <a:ln>
+            <a:noFill/>
+          </a:ln>
+          <a:effectLst/>
+          <a:extLst>
+            <a:ext uri="{909E8E84-426E-40DD-AFC4-6F175D3DCCD1}">
+              <a14:hiddenFill xmlns:a14="http://schemas.microsoft.com/office/drawing/2010/main">
+                <a:solidFill>
+                  <a:schemeClr val="accent1"/>
+                </a:solidFill>
+              </a14:hiddenFill>
+            </a:ext>
+            <a:ext uri="{91240B29-F687-4F45-9708-019B960494DF}">
+              <a14:hiddenLine xmlns:a14="http://schemas.microsoft.com/office/drawing/2010/main" w="25400" cap="sq">
+                <a:solidFill>
+                  <a:schemeClr val="tx1"/>
+                </a:solidFill>
+                <a:miter lim="800000"/>
+                <a:headEnd/>
+                <a:tailEnd/>
+              </a14:hiddenLine>
+            </a:ext>
+            <a:ext uri="{AF507438-7753-43E0-B8FC-AC1667EBCBE1}">
+              <a14:hiddenEffects xmlns:a14="http://schemas.microsoft.com/office/drawing/2010/main">
+                <a:effectLst>
+                  <a:outerShdw dist="35921" dir="2700000" algn="ctr" rotWithShape="0">
+                    <a:schemeClr val="bg2"/>
+                  </a:outerShdw>
+                </a:effectLst>
+              </a14:hiddenEffects>
+            </a:ext>
+          </a:extLst>
+        </p:spPr>
+      </p:pic>
+      <p:sp>
+        <p:nvSpPr>
+          <p:cNvPr id="6" name="TextBox 5">
+            <a:extLst>
+              <a:ext uri="{FF2B5EF4-FFF2-40B4-BE49-F238E27FC236}">
+                <a16:creationId xmlns:a16="http://schemas.microsoft.com/office/drawing/2014/main" id="{053A53C2-7F80-0121-270D-6C220D217729}"/>
+              </a:ext>
+            </a:extLst>
+          </p:cNvPr>
+          <p:cNvSpPr txBox="1"/>
+          <p:nvPr/>
+        </p:nvSpPr>
+        <p:spPr>
+          <a:xfrm>
+            <a:off x="5943600" y="2133600"/>
+            <a:ext cx="2895600" cy="3400931"/>
+          </a:xfrm>
+          <a:prstGeom prst="rect">
+            <a:avLst/>
+          </a:prstGeom>
+          <a:noFill/>
+        </p:spPr>
+        <p:txBody>
+          <a:bodyPr wrap="square">
+            <a:spAutoFit/>
+          </a:bodyPr>
+          <a:lstStyle/>
+          <a:p>
+            <a:pPr marL="285750" indent="-285750">
+              <a:spcBef>
+                <a:spcPts val="600"/>
+              </a:spcBef>
+              <a:buFont typeface="Arial" panose="020B0604020202020204" pitchFamily="34" charset="0"/>
+              <a:buChar char="•"/>
+            </a:pPr>
+            <a:r>
+              <a:rPr lang="en-US" dirty="0"/>
+              <a:t>When S = 0:</a:t>
+            </a:r>
+          </a:p>
+          <a:p>
+            <a:pPr marL="742950" lvl="1" indent="-285750">
+              <a:spcBef>
+                <a:spcPts val="600"/>
+              </a:spcBef>
+              <a:buFont typeface="Arial" panose="020B0604020202020204" pitchFamily="34" charset="0"/>
+              <a:buChar char="•"/>
+            </a:pPr>
+            <a:r>
+              <a:rPr lang="en-US" dirty="0"/>
+              <a:t>Inputs are A and B</a:t>
+            </a:r>
+          </a:p>
+          <a:p>
+            <a:pPr marL="742950" lvl="1" indent="-285750">
+              <a:spcBef>
+                <a:spcPts val="600"/>
+              </a:spcBef>
+              <a:buFont typeface="Arial" panose="020B0604020202020204" pitchFamily="34" charset="0"/>
+              <a:buChar char="•"/>
+            </a:pPr>
+            <a:r>
+              <a:rPr lang="en-US" dirty="0"/>
+              <a:t>Result is A + B</a:t>
+            </a:r>
+          </a:p>
+          <a:p>
+            <a:pPr marL="742950" lvl="1" indent="-285750">
+              <a:spcBef>
+                <a:spcPts val="600"/>
+              </a:spcBef>
+              <a:buFont typeface="Arial" panose="020B0604020202020204" pitchFamily="34" charset="0"/>
+              <a:buChar char="•"/>
+            </a:pPr>
+            <a:endParaRPr lang="en-US" dirty="0"/>
+          </a:p>
+          <a:p>
+            <a:pPr marL="285750" indent="-285750">
+              <a:spcBef>
+                <a:spcPts val="600"/>
+              </a:spcBef>
+              <a:buFont typeface="Arial" panose="020B0604020202020204" pitchFamily="34" charset="0"/>
+              <a:buChar char="•"/>
+            </a:pPr>
+            <a:r>
+              <a:rPr lang="en-US" dirty="0"/>
+              <a:t>When S = 1:</a:t>
+            </a:r>
+          </a:p>
+          <a:p>
+            <a:pPr marL="742950" lvl="1" indent="-285750">
+              <a:spcBef>
+                <a:spcPts val="600"/>
+              </a:spcBef>
+              <a:buFont typeface="Arial" panose="020B0604020202020204" pitchFamily="34" charset="0"/>
+              <a:buChar char="•"/>
+            </a:pPr>
+            <a:r>
+              <a:rPr lang="en-US" dirty="0"/>
+              <a:t>Inputs become A and B’</a:t>
+            </a:r>
+          </a:p>
+          <a:p>
+            <a:pPr marL="742950" lvl="1" indent="-285750">
+              <a:spcBef>
+                <a:spcPts val="600"/>
+              </a:spcBef>
+              <a:buFont typeface="Arial" panose="020B0604020202020204" pitchFamily="34" charset="0"/>
+              <a:buChar char="•"/>
+            </a:pPr>
+            <a:r>
+              <a:rPr lang="en-US" dirty="0"/>
+              <a:t>C</a:t>
+            </a:r>
+            <a:r>
+              <a:rPr lang="en-US" baseline="-25000" dirty="0"/>
+              <a:t>0</a:t>
+            </a:r>
+            <a:r>
+              <a:rPr lang="en-US" dirty="0"/>
+              <a:t> = 1, so 1 is added to A + B’</a:t>
+            </a:r>
+          </a:p>
+          <a:p>
+            <a:pPr marL="742950" lvl="1" indent="-285750">
+              <a:spcBef>
+                <a:spcPts val="600"/>
+              </a:spcBef>
+              <a:buFont typeface="Arial" panose="020B0604020202020204" pitchFamily="34" charset="0"/>
+              <a:buChar char="•"/>
+            </a:pPr>
+            <a:r>
+              <a:rPr lang="en-US" dirty="0"/>
+              <a:t>Result is A - B</a:t>
+            </a:r>
+            <a:endParaRPr lang="en-IN" dirty="0"/>
+          </a:p>
+        </p:txBody>
+      </p:sp>
+      <p:sp>
+        <p:nvSpPr>
+          <p:cNvPr id="7" name="TextBox 6">
+            <a:extLst>
+              <a:ext uri="{FF2B5EF4-FFF2-40B4-BE49-F238E27FC236}">
+                <a16:creationId xmlns:a16="http://schemas.microsoft.com/office/drawing/2014/main" id="{58F58500-E29C-0874-045A-5515C9306836}"/>
+              </a:ext>
+            </a:extLst>
+          </p:cNvPr>
+          <p:cNvSpPr txBox="1"/>
+          <p:nvPr/>
+        </p:nvSpPr>
+        <p:spPr>
+          <a:xfrm>
+            <a:off x="163543" y="4724400"/>
+            <a:ext cx="5562600" cy="1703030"/>
+          </a:xfrm>
+          <a:prstGeom prst="rect">
+            <a:avLst/>
+          </a:prstGeom>
+          <a:noFill/>
+        </p:spPr>
+        <p:txBody>
+          <a:bodyPr wrap="square">
+            <a:spAutoFit/>
+          </a:bodyPr>
+          <a:lstStyle/>
+          <a:p>
+            <a:pPr marL="285750" indent="-285750">
+              <a:lnSpc>
+                <a:spcPct val="150000"/>
+              </a:lnSpc>
+              <a:buFont typeface="Arial" panose="020B0604020202020204" pitchFamily="34" charset="0"/>
+              <a:buChar char="•"/>
+            </a:pPr>
+            <a:r>
+              <a:rPr lang="en-US" dirty="0"/>
+              <a:t>XOR gate acts as a programmable inverter!</a:t>
+            </a:r>
+          </a:p>
+          <a:p>
+            <a:pPr marL="285750" indent="-285750">
+              <a:lnSpc>
+                <a:spcPct val="150000"/>
+              </a:lnSpc>
+              <a:buFont typeface="Arial" panose="020B0604020202020204" pitchFamily="34" charset="0"/>
+              <a:buChar char="•"/>
+            </a:pPr>
+            <a:r>
+              <a:rPr lang="en-US" dirty="0"/>
+              <a:t>Is the subtraction result correct as is?</a:t>
+            </a:r>
+          </a:p>
+          <a:p>
+            <a:pPr marL="285750" indent="-285750">
+              <a:lnSpc>
+                <a:spcPct val="150000"/>
+              </a:lnSpc>
+              <a:buFont typeface="Arial" panose="020B0604020202020204" pitchFamily="34" charset="0"/>
+              <a:buChar char="•"/>
+            </a:pPr>
+            <a:r>
+              <a:rPr lang="en-IN" dirty="0"/>
+              <a:t>When A &gt; B?</a:t>
+            </a:r>
+          </a:p>
+          <a:p>
+            <a:pPr marL="285750" indent="-285750">
+              <a:lnSpc>
+                <a:spcPct val="150000"/>
+              </a:lnSpc>
+              <a:buFont typeface="Arial" panose="020B0604020202020204" pitchFamily="34" charset="0"/>
+              <a:buChar char="•"/>
+            </a:pPr>
+            <a:r>
+              <a:rPr lang="en-IN" dirty="0"/>
+              <a:t>When B &gt; A?</a:t>
+            </a:r>
+          </a:p>
+        </p:txBody>
+      </p:sp>
+    </p:spTree>
+    <p:extLst>
+      <p:ext uri="{BB962C8B-B14F-4D97-AF65-F5344CB8AC3E}">
+        <p14:creationId xmlns:p14="http://schemas.microsoft.com/office/powerpoint/2010/main" val="2282774737"/>
+      </p:ext>
+    </p:extLst>
+  </p:cSld>
+  <p:clrMapOvr>
+    <a:masterClrMapping/>
+  </p:clrMapOvr>
+  <p:timing>
+    <p:tnLst>
+      <p:par>
+        <p:cTn id="1" dur="indefinite" restart="never" nodeType="tmRoot">
+          <p:childTnLst>
+            <p:seq concurrent="1" nextAc="seek">
+              <p:cTn id="2" dur="indefinite" nodeType="mainSeq">
+                <p:childTnLst>
+                  <p:par>
+                    <p:cTn id="3" fill="hold">
+                      <p:stCondLst>
+                        <p:cond delay="indefinite"/>
+                      </p:stCondLst>
+                      <p:childTnLst>
+                        <p:par>
+                          <p:cTn id="4" fill="hold">
+                            <p:stCondLst>
+                              <p:cond delay="0"/>
+                            </p:stCondLst>
+                            <p:childTnLst>
+                              <p:par>
+                                <p:cTn id="5" presetID="1" presetClass="entr" presetSubtype="0" fill="hold" grpId="0" nodeType="clickEffect">
+                                  <p:stCondLst>
+                                    <p:cond delay="0"/>
+                                  </p:stCondLst>
+                                  <p:childTnLst>
+                                    <p:set>
+                                      <p:cBhvr>
+                                        <p:cTn id="6" dur="1" fill="hold">
+                                          <p:stCondLst>
+                                            <p:cond delay="0"/>
+                                          </p:stCondLst>
+                                        </p:cTn>
+                                        <p:tgtEl>
+                                          <p:spTgt spid="6">
+                                            <p:txEl>
+                                              <p:pRg st="0" end="0"/>
+                                            </p:txEl>
+                                          </p:spTgt>
+                                        </p:tgtEl>
+                                        <p:attrNameLst>
+                                          <p:attrName>style.visibility</p:attrName>
+                                        </p:attrNameLst>
+                                      </p:cBhvr>
+                                      <p:to>
+                                        <p:strVal val="visible"/>
+                                      </p:to>
+                                    </p:set>
+                                  </p:childTnLst>
+                                </p:cTn>
+                              </p:par>
+                            </p:childTnLst>
+                          </p:cTn>
+                        </p:par>
+                      </p:childTnLst>
+                    </p:cTn>
+                  </p:par>
+                  <p:par>
+                    <p:cTn id="7" fill="hold">
+                      <p:stCondLst>
+                        <p:cond delay="indefinite"/>
+                      </p:stCondLst>
+                      <p:childTnLst>
+                        <p:par>
+                          <p:cTn id="8" fill="hold">
+                            <p:stCondLst>
+                              <p:cond delay="0"/>
+                            </p:stCondLst>
+                            <p:childTnLst>
+                              <p:par>
+                                <p:cTn id="9" presetID="1" presetClass="entr" presetSubtype="0" fill="hold" grpId="0" nodeType="clickEffect">
+                                  <p:stCondLst>
+                                    <p:cond delay="0"/>
+                                  </p:stCondLst>
+                                  <p:childTnLst>
+                                    <p:set>
+                                      <p:cBhvr>
+                                        <p:cTn id="10" dur="1" fill="hold">
+                                          <p:stCondLst>
+                                            <p:cond delay="0"/>
+                                          </p:stCondLst>
+                                        </p:cTn>
+                                        <p:tgtEl>
+                                          <p:spTgt spid="6">
+                                            <p:txEl>
+                                              <p:pRg st="1" end="1"/>
+                                            </p:txEl>
+                                          </p:spTgt>
+                                        </p:tgtEl>
+                                        <p:attrNameLst>
+                                          <p:attrName>style.visibility</p:attrName>
+                                        </p:attrNameLst>
+                                      </p:cBhvr>
+                                      <p:to>
+                                        <p:strVal val="visible"/>
+                                      </p:to>
+                                    </p:set>
+                                  </p:childTnLst>
+                                </p:cTn>
+                              </p:par>
+                            </p:childTnLst>
+                          </p:cTn>
+                        </p:par>
+                      </p:childTnLst>
+                    </p:cTn>
+                  </p:par>
+                  <p:par>
+                    <p:cTn id="11" fill="hold">
+                      <p:stCondLst>
+                        <p:cond delay="indefinite"/>
+                      </p:stCondLst>
+                      <p:childTnLst>
+                        <p:par>
+                          <p:cTn id="12" fill="hold">
+                            <p:stCondLst>
+                              <p:cond delay="0"/>
+                            </p:stCondLst>
+                            <p:childTnLst>
+                              <p:par>
+                                <p:cTn id="13" presetID="1" presetClass="entr" presetSubtype="0" fill="hold" grpId="0" nodeType="clickEffect">
+                                  <p:stCondLst>
+                                    <p:cond delay="0"/>
+                                  </p:stCondLst>
+                                  <p:childTnLst>
+                                    <p:set>
+                                      <p:cBhvr>
+                                        <p:cTn id="14" dur="1" fill="hold">
+                                          <p:stCondLst>
+                                            <p:cond delay="0"/>
+                                          </p:stCondLst>
+                                        </p:cTn>
+                                        <p:tgtEl>
+                                          <p:spTgt spid="6">
+                                            <p:txEl>
+                                              <p:pRg st="2" end="2"/>
+                                            </p:txEl>
+                                          </p:spTgt>
+                                        </p:tgtEl>
+                                        <p:attrNameLst>
+                                          <p:attrName>style.visibility</p:attrName>
+                                        </p:attrNameLst>
+                                      </p:cBhvr>
+                                      <p:to>
+                                        <p:strVal val="visible"/>
+                                      </p:to>
+                                    </p:set>
+                                  </p:childTnLst>
+                                </p:cTn>
+                              </p:par>
+                            </p:childTnLst>
+                          </p:cTn>
+                        </p:par>
+                      </p:childTnLst>
+                    </p:cTn>
+                  </p:par>
+                  <p:par>
+                    <p:cTn id="15" fill="hold">
+                      <p:stCondLst>
+                        <p:cond delay="indefinite"/>
+                      </p:stCondLst>
+                      <p:childTnLst>
+                        <p:par>
+                          <p:cTn id="16" fill="hold">
+                            <p:stCondLst>
+                              <p:cond delay="0"/>
+                            </p:stCondLst>
+                            <p:childTnLst>
+                              <p:par>
+                                <p:cTn id="17" presetID="1" presetClass="entr" presetSubtype="0" fill="hold" grpId="0" nodeType="clickEffect">
+                                  <p:stCondLst>
+                                    <p:cond delay="0"/>
+                                  </p:stCondLst>
+                                  <p:childTnLst>
+                                    <p:set>
+                                      <p:cBhvr>
+                                        <p:cTn id="18" dur="1" fill="hold">
+                                          <p:stCondLst>
+                                            <p:cond delay="0"/>
+                                          </p:stCondLst>
+                                        </p:cTn>
+                                        <p:tgtEl>
+                                          <p:spTgt spid="6">
+                                            <p:txEl>
+                                              <p:pRg st="4" end="4"/>
+                                            </p:txEl>
+                                          </p:spTgt>
+                                        </p:tgtEl>
+                                        <p:attrNameLst>
+                                          <p:attrName>style.visibility</p:attrName>
+                                        </p:attrNameLst>
+                                      </p:cBhvr>
+                                      <p:to>
+                                        <p:strVal val="visible"/>
+                                      </p:to>
+                                    </p:set>
+                                  </p:childTnLst>
+                                </p:cTn>
+                              </p:par>
+                            </p:childTnLst>
+                          </p:cTn>
+                        </p:par>
+                      </p:childTnLst>
+                    </p:cTn>
+                  </p:par>
+                  <p:par>
+                    <p:cTn id="19" fill="hold">
+                      <p:stCondLst>
+                        <p:cond delay="indefinite"/>
+                      </p:stCondLst>
+                      <p:childTnLst>
+                        <p:par>
+                          <p:cTn id="20" fill="hold">
+                            <p:stCondLst>
+                              <p:cond delay="0"/>
+                            </p:stCondLst>
+                            <p:childTnLst>
+                              <p:par>
+                                <p:cTn id="21" presetID="1" presetClass="entr" presetSubtype="0" fill="hold" grpId="0" nodeType="clickEffect">
+                                  <p:stCondLst>
+                                    <p:cond delay="0"/>
+                                  </p:stCondLst>
+                                  <p:childTnLst>
+                                    <p:set>
+                                      <p:cBhvr>
+                                        <p:cTn id="22" dur="1" fill="hold">
+                                          <p:stCondLst>
+                                            <p:cond delay="0"/>
+                                          </p:stCondLst>
+                                        </p:cTn>
+                                        <p:tgtEl>
+                                          <p:spTgt spid="6">
+                                            <p:txEl>
+                                              <p:pRg st="5" end="5"/>
+                                            </p:txEl>
+                                          </p:spTgt>
+                                        </p:tgtEl>
+                                        <p:attrNameLst>
+                                          <p:attrName>style.visibility</p:attrName>
+                                        </p:attrNameLst>
+                                      </p:cBhvr>
+                                      <p:to>
+                                        <p:strVal val="visible"/>
+                                      </p:to>
+                                    </p:set>
+                                  </p:childTnLst>
+                                </p:cTn>
+                              </p:par>
+                            </p:childTnLst>
+                          </p:cTn>
+                        </p:par>
+                      </p:childTnLst>
+                    </p:cTn>
+                  </p:par>
+                  <p:par>
+                    <p:cTn id="23" fill="hold">
+                      <p:stCondLst>
+                        <p:cond delay="indefinite"/>
+                      </p:stCondLst>
+                      <p:childTnLst>
+                        <p:par>
+                          <p:cTn id="24" fill="hold">
+                            <p:stCondLst>
+                              <p:cond delay="0"/>
+                            </p:stCondLst>
+                            <p:childTnLst>
+                              <p:par>
+                                <p:cTn id="25" presetID="1" presetClass="entr" presetSubtype="0" fill="hold" grpId="0" nodeType="clickEffect">
+                                  <p:stCondLst>
+                                    <p:cond delay="0"/>
+                                  </p:stCondLst>
+                                  <p:childTnLst>
+                                    <p:set>
+                                      <p:cBhvr>
+                                        <p:cTn id="26" dur="1" fill="hold">
+                                          <p:stCondLst>
+                                            <p:cond delay="0"/>
+                                          </p:stCondLst>
+                                        </p:cTn>
+                                        <p:tgtEl>
+                                          <p:spTgt spid="6">
+                                            <p:txEl>
+                                              <p:pRg st="6" end="6"/>
+                                            </p:txEl>
+                                          </p:spTgt>
+                                        </p:tgtEl>
+                                        <p:attrNameLst>
+                                          <p:attrName>style.visibility</p:attrName>
+                                        </p:attrNameLst>
+                                      </p:cBhvr>
+                                      <p:to>
+                                        <p:strVal val="visible"/>
+                                      </p:to>
+                                    </p:set>
+                                  </p:childTnLst>
+                                </p:cTn>
+                              </p:par>
+                            </p:childTnLst>
+                          </p:cTn>
+                        </p:par>
+                      </p:childTnLst>
+                    </p:cTn>
+                  </p:par>
+                  <p:par>
+                    <p:cTn id="27" fill="hold">
+                      <p:stCondLst>
+                        <p:cond delay="indefinite"/>
+                      </p:stCondLst>
+                      <p:childTnLst>
+                        <p:par>
+                          <p:cTn id="28" fill="hold">
+                            <p:stCondLst>
+                              <p:cond delay="0"/>
+                            </p:stCondLst>
+                            <p:childTnLst>
+                              <p:par>
+                                <p:cTn id="29" presetID="1" presetClass="entr" presetSubtype="0" fill="hold" grpId="0" nodeType="clickEffect">
+                                  <p:stCondLst>
+                                    <p:cond delay="0"/>
+                                  </p:stCondLst>
+                                  <p:childTnLst>
+                                    <p:set>
+                                      <p:cBhvr>
+                                        <p:cTn id="30" dur="1" fill="hold">
+                                          <p:stCondLst>
+                                            <p:cond delay="0"/>
+                                          </p:stCondLst>
+                                        </p:cTn>
+                                        <p:tgtEl>
+                                          <p:spTgt spid="6">
+                                            <p:txEl>
+                                              <p:pRg st="7" end="7"/>
+                                            </p:txEl>
+                                          </p:spTgt>
+                                        </p:tgtEl>
+                                        <p:attrNameLst>
+                                          <p:attrName>style.visibility</p:attrName>
+                                        </p:attrNameLst>
+                                      </p:cBhvr>
+                                      <p:to>
+                                        <p:strVal val="visible"/>
+                                      </p:to>
+                                    </p:set>
+                                  </p:childTnLst>
+                                </p:cTn>
+                              </p:par>
+                            </p:childTnLst>
+                          </p:cTn>
+                        </p:par>
+                      </p:childTnLst>
+                    </p:cTn>
+                  </p:par>
+                  <p:par>
+                    <p:cTn id="31" fill="hold">
+                      <p:stCondLst>
+                        <p:cond delay="indefinite"/>
+                      </p:stCondLst>
+                      <p:childTnLst>
+                        <p:par>
+                          <p:cTn id="32" fill="hold">
+                            <p:stCondLst>
+                              <p:cond delay="0"/>
+                            </p:stCondLst>
+                            <p:childTnLst>
+                              <p:par>
+                                <p:cTn id="33" presetID="1" presetClass="entr" presetSubtype="0" fill="hold" grpId="0" nodeType="clickEffect">
+                                  <p:stCondLst>
+                                    <p:cond delay="0"/>
+                                  </p:stCondLst>
+                                  <p:childTnLst>
+                                    <p:set>
+                                      <p:cBhvr>
+                                        <p:cTn id="34" dur="1" fill="hold">
+                                          <p:stCondLst>
+                                            <p:cond delay="0"/>
+                                          </p:stCondLst>
+                                        </p:cTn>
+                                        <p:tgtEl>
+                                          <p:spTgt spid="7">
+                                            <p:txEl>
+                                              <p:pRg st="0" end="0"/>
+                                            </p:txEl>
+                                          </p:spTgt>
+                                        </p:tgtEl>
+                                        <p:attrNameLst>
+                                          <p:attrName>style.visibility</p:attrName>
+                                        </p:attrNameLst>
+                                      </p:cBhvr>
+                                      <p:to>
+                                        <p:strVal val="visible"/>
+                                      </p:to>
+                                    </p:set>
+                                  </p:childTnLst>
+                                </p:cTn>
+                              </p:par>
+                            </p:childTnLst>
+                          </p:cTn>
+                        </p:par>
+                      </p:childTnLst>
+                    </p:cTn>
+                  </p:par>
+                  <p:par>
+                    <p:cTn id="35" fill="hold">
+                      <p:stCondLst>
+                        <p:cond delay="indefinite"/>
+                      </p:stCondLst>
+                      <p:childTnLst>
+                        <p:par>
+                          <p:cTn id="36" fill="hold">
+                            <p:stCondLst>
+                              <p:cond delay="0"/>
+                            </p:stCondLst>
+                            <p:childTnLst>
+                              <p:par>
+                                <p:cTn id="37" presetID="1" presetClass="entr" presetSubtype="0" fill="hold" grpId="0" nodeType="clickEffect">
+                                  <p:stCondLst>
+                                    <p:cond delay="0"/>
+                                  </p:stCondLst>
+                                  <p:childTnLst>
+                                    <p:set>
+                                      <p:cBhvr>
+                                        <p:cTn id="38" dur="1" fill="hold">
+                                          <p:stCondLst>
+                                            <p:cond delay="0"/>
+                                          </p:stCondLst>
+                                        </p:cTn>
+                                        <p:tgtEl>
+                                          <p:spTgt spid="7">
+                                            <p:txEl>
+                                              <p:pRg st="1" end="1"/>
+                                            </p:txEl>
+                                          </p:spTgt>
+                                        </p:tgtEl>
+                                        <p:attrNameLst>
+                                          <p:attrName>style.visibility</p:attrName>
+                                        </p:attrNameLst>
+                                      </p:cBhvr>
+                                      <p:to>
+                                        <p:strVal val="visible"/>
+                                      </p:to>
+                                    </p:set>
+                                  </p:childTnLst>
+                                </p:cTn>
+                              </p:par>
+                            </p:childTnLst>
+                          </p:cTn>
+                        </p:par>
+                      </p:childTnLst>
+                    </p:cTn>
+                  </p:par>
+                  <p:par>
+                    <p:cTn id="39" fill="hold">
+                      <p:stCondLst>
+                        <p:cond delay="indefinite"/>
+                      </p:stCondLst>
+                      <p:childTnLst>
+                        <p:par>
+                          <p:cTn id="40" fill="hold">
+                            <p:stCondLst>
+                              <p:cond delay="0"/>
+                            </p:stCondLst>
+                            <p:childTnLst>
+                              <p:par>
+                                <p:cTn id="41" presetID="1" presetClass="entr" presetSubtype="0" fill="hold" grpId="0" nodeType="clickEffect">
+                                  <p:stCondLst>
+                                    <p:cond delay="0"/>
+                                  </p:stCondLst>
+                                  <p:childTnLst>
+                                    <p:set>
+                                      <p:cBhvr>
+                                        <p:cTn id="42" dur="1" fill="hold">
+                                          <p:stCondLst>
+                                            <p:cond delay="0"/>
+                                          </p:stCondLst>
+                                        </p:cTn>
+                                        <p:tgtEl>
+                                          <p:spTgt spid="7">
+                                            <p:txEl>
+                                              <p:pRg st="2" end="2"/>
+                                            </p:txEl>
+                                          </p:spTgt>
+                                        </p:tgtEl>
+                                        <p:attrNameLst>
+                                          <p:attrName>style.visibility</p:attrName>
+                                        </p:attrNameLst>
+                                      </p:cBhvr>
+                                      <p:to>
+                                        <p:strVal val="visible"/>
+                                      </p:to>
+                                    </p:set>
+                                  </p:childTnLst>
+                                </p:cTn>
+                              </p:par>
+                            </p:childTnLst>
+                          </p:cTn>
+                        </p:par>
+                      </p:childTnLst>
+                    </p:cTn>
+                  </p:par>
+                  <p:par>
+                    <p:cTn id="43" fill="hold">
+                      <p:stCondLst>
+                        <p:cond delay="indefinite"/>
+                      </p:stCondLst>
+                      <p:childTnLst>
+                        <p:par>
+                          <p:cTn id="44" fill="hold">
+                            <p:stCondLst>
+                              <p:cond delay="0"/>
+                            </p:stCondLst>
+                            <p:childTnLst>
+                              <p:par>
+                                <p:cTn id="45" presetID="1" presetClass="entr" presetSubtype="0" fill="hold" grpId="0" nodeType="clickEffect">
+                                  <p:stCondLst>
+                                    <p:cond delay="0"/>
+                                  </p:stCondLst>
+                                  <p:childTnLst>
+                                    <p:set>
+                                      <p:cBhvr>
+                                        <p:cTn id="46" dur="1" fill="hold">
+                                          <p:stCondLst>
+                                            <p:cond delay="0"/>
+                                          </p:stCondLst>
+                                        </p:cTn>
+                                        <p:tgtEl>
+                                          <p:spTgt spid="7">
+                                            <p:txEl>
+                                              <p:pRg st="3" end="3"/>
+                                            </p:txEl>
+                                          </p:spTgt>
+                                        </p:tgtEl>
+                                        <p:attrNameLst>
+                                          <p:attrName>style.visibility</p:attrName>
+                                        </p:attrNameLst>
+                                      </p:cBhvr>
+                                      <p:to>
+                                        <p:strVal val="visible"/>
+                                      </p:to>
+                                    </p:set>
+                                  </p:childTnLst>
+                                </p:cTn>
+                              </p:par>
+                            </p:childTnLst>
+                          </p:cTn>
+                        </p:par>
+                      </p:childTnLst>
+                    </p:cTn>
+                  </p:par>
+                </p:childTnLst>
+              </p:cTn>
+              <p:prevCondLst>
+                <p:cond evt="onPrev" delay="0">
+                  <p:tgtEl>
+                    <p:sldTgt/>
+                  </p:tgtEl>
+                </p:cond>
+              </p:prevCondLst>
+              <p:nextCondLst>
+                <p:cond evt="onNext" delay="0">
+                  <p:tgtEl>
+                    <p:sldTgt/>
+                  </p:tgtEl>
+                </p:cond>
+              </p:nextCondLst>
+            </p:seq>
+          </p:childTnLst>
+        </p:cTn>
+      </p:par>
+    </p:tnLst>
+    <p:bldLst>
+      <p:bldP spid="6" grpId="0" build="p"/>
+      <p:bldP spid="7" grpId="0" build="p"/>
+    </p:bldLst>
+  </p:timing>
+</p:sld>
+</file>
+
+<file path=ppt/slides/slide15.xml><?xml version="1.0" encoding="utf-8"?>
+<p:sld xmlns:a="http://schemas.openxmlformats.org/drawingml/2006/main" xmlns:r="http://schemas.openxmlformats.org/officeDocument/2006/relationships" xmlns:p="http://schemas.openxmlformats.org/presentationml/2006/main">
+  <p:cSld>
+    <p:spTree>
+      <p:nvGrpSpPr>
+        <p:cNvPr id="1" name=""/>
+        <p:cNvGrpSpPr/>
+        <p:nvPr/>
+      </p:nvGrpSpPr>
+      <p:grpSpPr>
+        <a:xfrm>
+          <a:off x="0" y="0"/>
+          <a:ext cx="0" cy="0"/>
+          <a:chOff x="0" y="0"/>
+          <a:chExt cx="0" cy="0"/>
+        </a:xfrm>
+      </p:grpSpPr>
+      <p:sp>
+        <p:nvSpPr>
           <p:cNvPr id="2" name="Content Placeholder 1">
             <a:extLst>
               <a:ext uri="{FF2B5EF4-FFF2-40B4-BE49-F238E27FC236}">
@@ -8397,994 +9329,6 @@
     </p:tnLst>
     <p:bldLst>
       <p:bldP spid="2" grpId="0" build="p"/>
-    </p:bldLst>
-  </p:timing>
-</p:sld>
-</file>
-
-<file path=ppt/slides/slide15.xml><?xml version="1.0" encoding="utf-8"?>
-<p:sld xmlns:a="http://schemas.openxmlformats.org/drawingml/2006/main" xmlns:r="http://schemas.openxmlformats.org/officeDocument/2006/relationships" xmlns:p="http://schemas.openxmlformats.org/presentationml/2006/main">
-  <p:cSld>
-    <p:spTree>
-      <p:nvGrpSpPr>
-        <p:cNvPr id="1" name=""/>
-        <p:cNvGrpSpPr/>
-        <p:nvPr/>
-      </p:nvGrpSpPr>
-      <p:grpSpPr>
-        <a:xfrm>
-          <a:off x="0" y="0"/>
-          <a:ext cx="0" cy="0"/>
-          <a:chOff x="0" y="0"/>
-          <a:chExt cx="0" cy="0"/>
-        </a:xfrm>
-      </p:grpSpPr>
-      <p:sp>
-        <p:nvSpPr>
-          <p:cNvPr id="3" name="Content Placeholder 2">
-            <a:extLst>
-              <a:ext uri="{FF2B5EF4-FFF2-40B4-BE49-F238E27FC236}">
-                <a16:creationId xmlns:a16="http://schemas.microsoft.com/office/drawing/2014/main" id="{860A1932-3B1E-BD8F-E960-6C9D68A298AD}"/>
-              </a:ext>
-            </a:extLst>
-          </p:cNvPr>
-          <p:cNvSpPr>
-            <a:spLocks noGrp="1"/>
-          </p:cNvSpPr>
-          <p:nvPr>
-            <p:ph sz="quarter" idx="10"/>
-          </p:nvPr>
-        </p:nvSpPr>
-        <p:spPr/>
-        <p:txBody>
-          <a:bodyPr/>
-          <a:lstStyle/>
-          <a:p>
-            <a:r>
-              <a:rPr lang="en-US" dirty="0"/>
-              <a:t>A 4-bit binary adder / subtractor</a:t>
-            </a:r>
-            <a:endParaRPr lang="en-IN" dirty="0"/>
-          </a:p>
-        </p:txBody>
-      </p:sp>
-      <p:pic>
-        <p:nvPicPr>
-          <p:cNvPr id="4" name="Content Placeholder 3">
-            <a:extLst>
-              <a:ext uri="{FF2B5EF4-FFF2-40B4-BE49-F238E27FC236}">
-                <a16:creationId xmlns:a16="http://schemas.microsoft.com/office/drawing/2014/main" id="{A4EDC30D-0116-E52F-B455-4CF64FC8EE64}"/>
-              </a:ext>
-            </a:extLst>
-          </p:cNvPr>
-          <p:cNvPicPr>
-            <a:picLocks noGrp="1" noChangeAspect="1" noChangeArrowheads="1"/>
-          </p:cNvPicPr>
-          <p:nvPr>
-            <p:ph idx="1"/>
-          </p:nvPr>
-        </p:nvPicPr>
-        <p:blipFill>
-          <a:blip r:embed="rId2">
-            <a:extLst>
-              <a:ext uri="{28A0092B-C50C-407E-A947-70E740481C1C}">
-                <a14:useLocalDpi xmlns:a14="http://schemas.microsoft.com/office/drawing/2010/main" val="0"/>
-              </a:ext>
-            </a:extLst>
-          </a:blip>
-          <a:srcRect l="33333" t="48148" r="19444" b="18518"/>
-          <a:stretch>
-            <a:fillRect/>
-          </a:stretch>
-        </p:blipFill>
-        <p:spPr bwMode="auto">
-          <a:xfrm>
-            <a:off x="76201" y="1524001"/>
-            <a:ext cx="5613380" cy="2971800"/>
-          </a:xfrm>
-          <a:prstGeom prst="rect">
-            <a:avLst/>
-          </a:prstGeom>
-          <a:noFill/>
-          <a:ln>
-            <a:noFill/>
-          </a:ln>
-          <a:effectLst/>
-          <a:extLst>
-            <a:ext uri="{909E8E84-426E-40DD-AFC4-6F175D3DCCD1}">
-              <a14:hiddenFill xmlns:a14="http://schemas.microsoft.com/office/drawing/2010/main">
-                <a:solidFill>
-                  <a:schemeClr val="accent1"/>
-                </a:solidFill>
-              </a14:hiddenFill>
-            </a:ext>
-            <a:ext uri="{91240B29-F687-4F45-9708-019B960494DF}">
-              <a14:hiddenLine xmlns:a14="http://schemas.microsoft.com/office/drawing/2010/main" w="25400" cap="sq">
-                <a:solidFill>
-                  <a:schemeClr val="tx1"/>
-                </a:solidFill>
-                <a:miter lim="800000"/>
-                <a:headEnd/>
-                <a:tailEnd/>
-              </a14:hiddenLine>
-            </a:ext>
-            <a:ext uri="{AF507438-7753-43E0-B8FC-AC1667EBCBE1}">
-              <a14:hiddenEffects xmlns:a14="http://schemas.microsoft.com/office/drawing/2010/main">
-                <a:effectLst>
-                  <a:outerShdw dist="35921" dir="2700000" algn="ctr" rotWithShape="0">
-                    <a:schemeClr val="bg2"/>
-                  </a:outerShdw>
-                </a:effectLst>
-              </a14:hiddenEffects>
-            </a:ext>
-          </a:extLst>
-        </p:spPr>
-      </p:pic>
-      <p:sp>
-        <p:nvSpPr>
-          <p:cNvPr id="6" name="TextBox 5">
-            <a:extLst>
-              <a:ext uri="{FF2B5EF4-FFF2-40B4-BE49-F238E27FC236}">
-                <a16:creationId xmlns:a16="http://schemas.microsoft.com/office/drawing/2014/main" id="{053A53C2-7F80-0121-270D-6C220D217729}"/>
-              </a:ext>
-            </a:extLst>
-          </p:cNvPr>
-          <p:cNvSpPr txBox="1"/>
-          <p:nvPr/>
-        </p:nvSpPr>
-        <p:spPr>
-          <a:xfrm>
-            <a:off x="5943600" y="2133600"/>
-            <a:ext cx="2895600" cy="4031873"/>
-          </a:xfrm>
-          <a:prstGeom prst="rect">
-            <a:avLst/>
-          </a:prstGeom>
-          <a:noFill/>
-        </p:spPr>
-        <p:txBody>
-          <a:bodyPr wrap="square">
-            <a:spAutoFit/>
-          </a:bodyPr>
-          <a:lstStyle/>
-          <a:p>
-            <a:pPr>
-              <a:spcBef>
-                <a:spcPts val="600"/>
-              </a:spcBef>
-            </a:pPr>
-            <a:r>
-              <a:rPr lang="en-US" dirty="0">
-                <a:solidFill>
-                  <a:srgbClr val="C00000"/>
-                </a:solidFill>
-              </a:rPr>
-              <a:t>How does this circuit work?</a:t>
-            </a:r>
-          </a:p>
-          <a:p>
-            <a:pPr marL="285750" indent="-285750">
-              <a:spcBef>
-                <a:spcPts val="600"/>
-              </a:spcBef>
-              <a:buFont typeface="Arial" panose="020B0604020202020204" pitchFamily="34" charset="0"/>
-              <a:buChar char="•"/>
-            </a:pPr>
-            <a:r>
-              <a:rPr lang="en-US" dirty="0"/>
-              <a:t>When S = 0:</a:t>
-            </a:r>
-          </a:p>
-          <a:p>
-            <a:pPr marL="742950" lvl="1" indent="-285750">
-              <a:spcBef>
-                <a:spcPts val="600"/>
-              </a:spcBef>
-              <a:buFont typeface="Arial" panose="020B0604020202020204" pitchFamily="34" charset="0"/>
-              <a:buChar char="•"/>
-            </a:pPr>
-            <a:r>
-              <a:rPr lang="en-US" dirty="0"/>
-              <a:t>Inputs are A and B</a:t>
-            </a:r>
-          </a:p>
-          <a:p>
-            <a:pPr marL="742950" lvl="1" indent="-285750">
-              <a:spcBef>
-                <a:spcPts val="600"/>
-              </a:spcBef>
-              <a:buFont typeface="Arial" panose="020B0604020202020204" pitchFamily="34" charset="0"/>
-              <a:buChar char="•"/>
-            </a:pPr>
-            <a:r>
-              <a:rPr lang="en-US" dirty="0"/>
-              <a:t>Result is A + B</a:t>
-            </a:r>
-          </a:p>
-          <a:p>
-            <a:pPr marL="742950" lvl="1" indent="-285750">
-              <a:spcBef>
-                <a:spcPts val="600"/>
-              </a:spcBef>
-              <a:buFont typeface="Arial" panose="020B0604020202020204" pitchFamily="34" charset="0"/>
-              <a:buChar char="•"/>
-            </a:pPr>
-            <a:endParaRPr lang="en-US" dirty="0"/>
-          </a:p>
-          <a:p>
-            <a:pPr marL="285750" indent="-285750">
-              <a:spcBef>
-                <a:spcPts val="600"/>
-              </a:spcBef>
-              <a:buFont typeface="Arial" panose="020B0604020202020204" pitchFamily="34" charset="0"/>
-              <a:buChar char="•"/>
-            </a:pPr>
-            <a:r>
-              <a:rPr lang="en-US" dirty="0"/>
-              <a:t>When S = 1:</a:t>
-            </a:r>
-          </a:p>
-          <a:p>
-            <a:pPr marL="742950" lvl="1" indent="-285750">
-              <a:spcBef>
-                <a:spcPts val="600"/>
-              </a:spcBef>
-              <a:buFont typeface="Arial" panose="020B0604020202020204" pitchFamily="34" charset="0"/>
-              <a:buChar char="•"/>
-            </a:pPr>
-            <a:r>
-              <a:rPr lang="en-US" dirty="0"/>
-              <a:t>Inputs become A and B’</a:t>
-            </a:r>
-          </a:p>
-          <a:p>
-            <a:pPr marL="742950" lvl="1" indent="-285750">
-              <a:spcBef>
-                <a:spcPts val="600"/>
-              </a:spcBef>
-              <a:buFont typeface="Arial" panose="020B0604020202020204" pitchFamily="34" charset="0"/>
-              <a:buChar char="•"/>
-            </a:pPr>
-            <a:r>
-              <a:rPr lang="en-US" dirty="0"/>
-              <a:t>C</a:t>
-            </a:r>
-            <a:r>
-              <a:rPr lang="en-US" baseline="-25000" dirty="0"/>
-              <a:t>0</a:t>
-            </a:r>
-            <a:r>
-              <a:rPr lang="en-US" dirty="0"/>
-              <a:t> = 1, so 1 is added to A + B’</a:t>
-            </a:r>
-          </a:p>
-          <a:p>
-            <a:pPr marL="742950" lvl="1" indent="-285750">
-              <a:spcBef>
-                <a:spcPts val="600"/>
-              </a:spcBef>
-              <a:buFont typeface="Arial" panose="020B0604020202020204" pitchFamily="34" charset="0"/>
-              <a:buChar char="•"/>
-            </a:pPr>
-            <a:r>
-              <a:rPr lang="en-US" dirty="0"/>
-              <a:t>Result is A - B</a:t>
-            </a:r>
-            <a:endParaRPr lang="en-IN" dirty="0"/>
-          </a:p>
-        </p:txBody>
-      </p:sp>
-      <p:sp>
-        <p:nvSpPr>
-          <p:cNvPr id="7" name="TextBox 6">
-            <a:extLst>
-              <a:ext uri="{FF2B5EF4-FFF2-40B4-BE49-F238E27FC236}">
-                <a16:creationId xmlns:a16="http://schemas.microsoft.com/office/drawing/2014/main" id="{58F58500-E29C-0874-045A-5515C9306836}"/>
-              </a:ext>
-            </a:extLst>
-          </p:cNvPr>
-          <p:cNvSpPr txBox="1"/>
-          <p:nvPr/>
-        </p:nvSpPr>
-        <p:spPr>
-          <a:xfrm>
-            <a:off x="163543" y="4724400"/>
-            <a:ext cx="5562600" cy="1703030"/>
-          </a:xfrm>
-          <a:prstGeom prst="rect">
-            <a:avLst/>
-          </a:prstGeom>
-          <a:noFill/>
-        </p:spPr>
-        <p:txBody>
-          <a:bodyPr wrap="square">
-            <a:spAutoFit/>
-          </a:bodyPr>
-          <a:lstStyle/>
-          <a:p>
-            <a:pPr marL="285750" indent="-285750">
-              <a:lnSpc>
-                <a:spcPct val="150000"/>
-              </a:lnSpc>
-              <a:buFont typeface="Arial" panose="020B0604020202020204" pitchFamily="34" charset="0"/>
-              <a:buChar char="•"/>
-            </a:pPr>
-            <a:r>
-              <a:rPr lang="en-US" dirty="0"/>
-              <a:t>XOR gate acts as a programmable inverter!</a:t>
-            </a:r>
-          </a:p>
-          <a:p>
-            <a:pPr marL="285750" indent="-285750">
-              <a:lnSpc>
-                <a:spcPct val="150000"/>
-              </a:lnSpc>
-              <a:buFont typeface="Arial" panose="020B0604020202020204" pitchFamily="34" charset="0"/>
-              <a:buChar char="•"/>
-            </a:pPr>
-            <a:r>
-              <a:rPr lang="en-US" dirty="0"/>
-              <a:t>Is the subtraction result correct as is?</a:t>
-            </a:r>
-          </a:p>
-          <a:p>
-            <a:pPr marL="285750" indent="-285750">
-              <a:lnSpc>
-                <a:spcPct val="150000"/>
-              </a:lnSpc>
-              <a:buFont typeface="Arial" panose="020B0604020202020204" pitchFamily="34" charset="0"/>
-              <a:buChar char="•"/>
-            </a:pPr>
-            <a:r>
-              <a:rPr lang="en-IN" dirty="0"/>
-              <a:t>When A &gt; B?</a:t>
-            </a:r>
-          </a:p>
-          <a:p>
-            <a:pPr marL="285750" indent="-285750">
-              <a:lnSpc>
-                <a:spcPct val="150000"/>
-              </a:lnSpc>
-              <a:buFont typeface="Arial" panose="020B0604020202020204" pitchFamily="34" charset="0"/>
-              <a:buChar char="•"/>
-            </a:pPr>
-            <a:r>
-              <a:rPr lang="en-IN" dirty="0"/>
-              <a:t>When B &gt; A?</a:t>
-            </a:r>
-          </a:p>
-        </p:txBody>
-      </p:sp>
-    </p:spTree>
-    <p:extLst>
-      <p:ext uri="{BB962C8B-B14F-4D97-AF65-F5344CB8AC3E}">
-        <p14:creationId xmlns:p14="http://schemas.microsoft.com/office/powerpoint/2010/main" val="2282774737"/>
-      </p:ext>
-    </p:extLst>
-  </p:cSld>
-  <p:clrMapOvr>
-    <a:masterClrMapping/>
-  </p:clrMapOvr>
-  <p:timing>
-    <p:tnLst>
-      <p:par>
-        <p:cTn id="1" dur="indefinite" restart="never" nodeType="tmRoot">
-          <p:childTnLst>
-            <p:seq concurrent="1" nextAc="seek">
-              <p:cTn id="2" dur="indefinite" nodeType="mainSeq">
-                <p:childTnLst>
-                  <p:par>
-                    <p:cTn id="3" fill="hold">
-                      <p:stCondLst>
-                        <p:cond delay="indefinite"/>
-                      </p:stCondLst>
-                      <p:childTnLst>
-                        <p:par>
-                          <p:cTn id="4" fill="hold">
-                            <p:stCondLst>
-                              <p:cond delay="0"/>
-                            </p:stCondLst>
-                            <p:childTnLst>
-                              <p:par>
-                                <p:cTn id="5" presetID="1" presetClass="entr" presetSubtype="0" fill="hold" grpId="0" nodeType="clickEffect">
-                                  <p:stCondLst>
-                                    <p:cond delay="0"/>
-                                  </p:stCondLst>
-                                  <p:childTnLst>
-                                    <p:set>
-                                      <p:cBhvr>
-                                        <p:cTn id="6" dur="1" fill="hold">
-                                          <p:stCondLst>
-                                            <p:cond delay="0"/>
-                                          </p:stCondLst>
-                                        </p:cTn>
-                                        <p:tgtEl>
-                                          <p:spTgt spid="6">
-                                            <p:txEl>
-                                              <p:pRg st="0" end="0"/>
-                                            </p:txEl>
-                                          </p:spTgt>
-                                        </p:tgtEl>
-                                        <p:attrNameLst>
-                                          <p:attrName>style.visibility</p:attrName>
-                                        </p:attrNameLst>
-                                      </p:cBhvr>
-                                      <p:to>
-                                        <p:strVal val="visible"/>
-                                      </p:to>
-                                    </p:set>
-                                  </p:childTnLst>
-                                </p:cTn>
-                              </p:par>
-                            </p:childTnLst>
-                          </p:cTn>
-                        </p:par>
-                      </p:childTnLst>
-                    </p:cTn>
-                  </p:par>
-                  <p:par>
-                    <p:cTn id="7" fill="hold">
-                      <p:stCondLst>
-                        <p:cond delay="indefinite"/>
-                      </p:stCondLst>
-                      <p:childTnLst>
-                        <p:par>
-                          <p:cTn id="8" fill="hold">
-                            <p:stCondLst>
-                              <p:cond delay="0"/>
-                            </p:stCondLst>
-                            <p:childTnLst>
-                              <p:par>
-                                <p:cTn id="9" presetID="1" presetClass="entr" presetSubtype="0" fill="hold" grpId="0" nodeType="clickEffect">
-                                  <p:stCondLst>
-                                    <p:cond delay="0"/>
-                                  </p:stCondLst>
-                                  <p:childTnLst>
-                                    <p:set>
-                                      <p:cBhvr>
-                                        <p:cTn id="10" dur="1" fill="hold">
-                                          <p:stCondLst>
-                                            <p:cond delay="0"/>
-                                          </p:stCondLst>
-                                        </p:cTn>
-                                        <p:tgtEl>
-                                          <p:spTgt spid="6">
-                                            <p:txEl>
-                                              <p:pRg st="1" end="1"/>
-                                            </p:txEl>
-                                          </p:spTgt>
-                                        </p:tgtEl>
-                                        <p:attrNameLst>
-                                          <p:attrName>style.visibility</p:attrName>
-                                        </p:attrNameLst>
-                                      </p:cBhvr>
-                                      <p:to>
-                                        <p:strVal val="visible"/>
-                                      </p:to>
-                                    </p:set>
-                                  </p:childTnLst>
-                                </p:cTn>
-                              </p:par>
-                            </p:childTnLst>
-                          </p:cTn>
-                        </p:par>
-                      </p:childTnLst>
-                    </p:cTn>
-                  </p:par>
-                  <p:par>
-                    <p:cTn id="11" fill="hold">
-                      <p:stCondLst>
-                        <p:cond delay="indefinite"/>
-                      </p:stCondLst>
-                      <p:childTnLst>
-                        <p:par>
-                          <p:cTn id="12" fill="hold">
-                            <p:stCondLst>
-                              <p:cond delay="0"/>
-                            </p:stCondLst>
-                            <p:childTnLst>
-                              <p:par>
-                                <p:cTn id="13" presetID="1" presetClass="entr" presetSubtype="0" fill="hold" grpId="0" nodeType="clickEffect">
-                                  <p:stCondLst>
-                                    <p:cond delay="0"/>
-                                  </p:stCondLst>
-                                  <p:childTnLst>
-                                    <p:set>
-                                      <p:cBhvr>
-                                        <p:cTn id="14" dur="1" fill="hold">
-                                          <p:stCondLst>
-                                            <p:cond delay="0"/>
-                                          </p:stCondLst>
-                                        </p:cTn>
-                                        <p:tgtEl>
-                                          <p:spTgt spid="6">
-                                            <p:txEl>
-                                              <p:pRg st="2" end="2"/>
-                                            </p:txEl>
-                                          </p:spTgt>
-                                        </p:tgtEl>
-                                        <p:attrNameLst>
-                                          <p:attrName>style.visibility</p:attrName>
-                                        </p:attrNameLst>
-                                      </p:cBhvr>
-                                      <p:to>
-                                        <p:strVal val="visible"/>
-                                      </p:to>
-                                    </p:set>
-                                  </p:childTnLst>
-                                </p:cTn>
-                              </p:par>
-                            </p:childTnLst>
-                          </p:cTn>
-                        </p:par>
-                      </p:childTnLst>
-                    </p:cTn>
-                  </p:par>
-                  <p:par>
-                    <p:cTn id="15" fill="hold">
-                      <p:stCondLst>
-                        <p:cond delay="indefinite"/>
-                      </p:stCondLst>
-                      <p:childTnLst>
-                        <p:par>
-                          <p:cTn id="16" fill="hold">
-                            <p:stCondLst>
-                              <p:cond delay="0"/>
-                            </p:stCondLst>
-                            <p:childTnLst>
-                              <p:par>
-                                <p:cTn id="17" presetID="1" presetClass="entr" presetSubtype="0" fill="hold" grpId="0" nodeType="clickEffect">
-                                  <p:stCondLst>
-                                    <p:cond delay="0"/>
-                                  </p:stCondLst>
-                                  <p:childTnLst>
-                                    <p:set>
-                                      <p:cBhvr>
-                                        <p:cTn id="18" dur="1" fill="hold">
-                                          <p:stCondLst>
-                                            <p:cond delay="0"/>
-                                          </p:stCondLst>
-                                        </p:cTn>
-                                        <p:tgtEl>
-                                          <p:spTgt spid="6">
-                                            <p:txEl>
-                                              <p:pRg st="3" end="3"/>
-                                            </p:txEl>
-                                          </p:spTgt>
-                                        </p:tgtEl>
-                                        <p:attrNameLst>
-                                          <p:attrName>style.visibility</p:attrName>
-                                        </p:attrNameLst>
-                                      </p:cBhvr>
-                                      <p:to>
-                                        <p:strVal val="visible"/>
-                                      </p:to>
-                                    </p:set>
-                                  </p:childTnLst>
-                                </p:cTn>
-                              </p:par>
-                            </p:childTnLst>
-                          </p:cTn>
-                        </p:par>
-                      </p:childTnLst>
-                    </p:cTn>
-                  </p:par>
-                  <p:par>
-                    <p:cTn id="19" fill="hold">
-                      <p:stCondLst>
-                        <p:cond delay="indefinite"/>
-                      </p:stCondLst>
-                      <p:childTnLst>
-                        <p:par>
-                          <p:cTn id="20" fill="hold">
-                            <p:stCondLst>
-                              <p:cond delay="0"/>
-                            </p:stCondLst>
-                            <p:childTnLst>
-                              <p:par>
-                                <p:cTn id="21" presetID="1" presetClass="entr" presetSubtype="0" fill="hold" grpId="0" nodeType="clickEffect">
-                                  <p:stCondLst>
-                                    <p:cond delay="0"/>
-                                  </p:stCondLst>
-                                  <p:childTnLst>
-                                    <p:set>
-                                      <p:cBhvr>
-                                        <p:cTn id="22" dur="1" fill="hold">
-                                          <p:stCondLst>
-                                            <p:cond delay="0"/>
-                                          </p:stCondLst>
-                                        </p:cTn>
-                                        <p:tgtEl>
-                                          <p:spTgt spid="6">
-                                            <p:txEl>
-                                              <p:pRg st="5" end="5"/>
-                                            </p:txEl>
-                                          </p:spTgt>
-                                        </p:tgtEl>
-                                        <p:attrNameLst>
-                                          <p:attrName>style.visibility</p:attrName>
-                                        </p:attrNameLst>
-                                      </p:cBhvr>
-                                      <p:to>
-                                        <p:strVal val="visible"/>
-                                      </p:to>
-                                    </p:set>
-                                  </p:childTnLst>
-                                </p:cTn>
-                              </p:par>
-                            </p:childTnLst>
-                          </p:cTn>
-                        </p:par>
-                      </p:childTnLst>
-                    </p:cTn>
-                  </p:par>
-                  <p:par>
-                    <p:cTn id="23" fill="hold">
-                      <p:stCondLst>
-                        <p:cond delay="indefinite"/>
-                      </p:stCondLst>
-                      <p:childTnLst>
-                        <p:par>
-                          <p:cTn id="24" fill="hold">
-                            <p:stCondLst>
-                              <p:cond delay="0"/>
-                            </p:stCondLst>
-                            <p:childTnLst>
-                              <p:par>
-                                <p:cTn id="25" presetID="1" presetClass="entr" presetSubtype="0" fill="hold" grpId="0" nodeType="clickEffect">
-                                  <p:stCondLst>
-                                    <p:cond delay="0"/>
-                                  </p:stCondLst>
-                                  <p:childTnLst>
-                                    <p:set>
-                                      <p:cBhvr>
-                                        <p:cTn id="26" dur="1" fill="hold">
-                                          <p:stCondLst>
-                                            <p:cond delay="0"/>
-                                          </p:stCondLst>
-                                        </p:cTn>
-                                        <p:tgtEl>
-                                          <p:spTgt spid="6">
-                                            <p:txEl>
-                                              <p:pRg st="6" end="6"/>
-                                            </p:txEl>
-                                          </p:spTgt>
-                                        </p:tgtEl>
-                                        <p:attrNameLst>
-                                          <p:attrName>style.visibility</p:attrName>
-                                        </p:attrNameLst>
-                                      </p:cBhvr>
-                                      <p:to>
-                                        <p:strVal val="visible"/>
-                                      </p:to>
-                                    </p:set>
-                                  </p:childTnLst>
-                                </p:cTn>
-                              </p:par>
-                            </p:childTnLst>
-                          </p:cTn>
-                        </p:par>
-                      </p:childTnLst>
-                    </p:cTn>
-                  </p:par>
-                  <p:par>
-                    <p:cTn id="27" fill="hold">
-                      <p:stCondLst>
-                        <p:cond delay="indefinite"/>
-                      </p:stCondLst>
-                      <p:childTnLst>
-                        <p:par>
-                          <p:cTn id="28" fill="hold">
-                            <p:stCondLst>
-                              <p:cond delay="0"/>
-                            </p:stCondLst>
-                            <p:childTnLst>
-                              <p:par>
-                                <p:cTn id="29" presetID="1" presetClass="entr" presetSubtype="0" fill="hold" grpId="0" nodeType="clickEffect">
-                                  <p:stCondLst>
-                                    <p:cond delay="0"/>
-                                  </p:stCondLst>
-                                  <p:childTnLst>
-                                    <p:set>
-                                      <p:cBhvr>
-                                        <p:cTn id="30" dur="1" fill="hold">
-                                          <p:stCondLst>
-                                            <p:cond delay="0"/>
-                                          </p:stCondLst>
-                                        </p:cTn>
-                                        <p:tgtEl>
-                                          <p:spTgt spid="6">
-                                            <p:txEl>
-                                              <p:pRg st="7" end="7"/>
-                                            </p:txEl>
-                                          </p:spTgt>
-                                        </p:tgtEl>
-                                        <p:attrNameLst>
-                                          <p:attrName>style.visibility</p:attrName>
-                                        </p:attrNameLst>
-                                      </p:cBhvr>
-                                      <p:to>
-                                        <p:strVal val="visible"/>
-                                      </p:to>
-                                    </p:set>
-                                  </p:childTnLst>
-                                </p:cTn>
-                              </p:par>
-                            </p:childTnLst>
-                          </p:cTn>
-                        </p:par>
-                      </p:childTnLst>
-                    </p:cTn>
-                  </p:par>
-                  <p:par>
-                    <p:cTn id="31" fill="hold">
-                      <p:stCondLst>
-                        <p:cond delay="indefinite"/>
-                      </p:stCondLst>
-                      <p:childTnLst>
-                        <p:par>
-                          <p:cTn id="32" fill="hold">
-                            <p:stCondLst>
-                              <p:cond delay="0"/>
-                            </p:stCondLst>
-                            <p:childTnLst>
-                              <p:par>
-                                <p:cTn id="33" presetID="1" presetClass="entr" presetSubtype="0" fill="hold" grpId="0" nodeType="clickEffect">
-                                  <p:stCondLst>
-                                    <p:cond delay="0"/>
-                                  </p:stCondLst>
-                                  <p:childTnLst>
-                                    <p:set>
-                                      <p:cBhvr>
-                                        <p:cTn id="34" dur="1" fill="hold">
-                                          <p:stCondLst>
-                                            <p:cond delay="0"/>
-                                          </p:stCondLst>
-                                        </p:cTn>
-                                        <p:tgtEl>
-                                          <p:spTgt spid="6">
-                                            <p:txEl>
-                                              <p:pRg st="8" end="8"/>
-                                            </p:txEl>
-                                          </p:spTgt>
-                                        </p:tgtEl>
-                                        <p:attrNameLst>
-                                          <p:attrName>style.visibility</p:attrName>
-                                        </p:attrNameLst>
-                                      </p:cBhvr>
-                                      <p:to>
-                                        <p:strVal val="visible"/>
-                                      </p:to>
-                                    </p:set>
-                                  </p:childTnLst>
-                                </p:cTn>
-                              </p:par>
-                            </p:childTnLst>
-                          </p:cTn>
-                        </p:par>
-                      </p:childTnLst>
-                    </p:cTn>
-                  </p:par>
-                  <p:par>
-                    <p:cTn id="35" fill="hold">
-                      <p:stCondLst>
-                        <p:cond delay="indefinite"/>
-                      </p:stCondLst>
-                      <p:childTnLst>
-                        <p:par>
-                          <p:cTn id="36" fill="hold">
-                            <p:stCondLst>
-                              <p:cond delay="0"/>
-                            </p:stCondLst>
-                            <p:childTnLst>
-                              <p:par>
-                                <p:cTn id="37" presetID="1" presetClass="entr" presetSubtype="0" fill="hold" grpId="0" nodeType="clickEffect">
-                                  <p:stCondLst>
-                                    <p:cond delay="0"/>
-                                  </p:stCondLst>
-                                  <p:childTnLst>
-                                    <p:set>
-                                      <p:cBhvr>
-                                        <p:cTn id="38" dur="1" fill="hold">
-                                          <p:stCondLst>
-                                            <p:cond delay="0"/>
-                                          </p:stCondLst>
-                                        </p:cTn>
-                                        <p:tgtEl>
-                                          <p:spTgt spid="7">
-                                            <p:txEl>
-                                              <p:pRg st="0" end="0"/>
-                                            </p:txEl>
-                                          </p:spTgt>
-                                        </p:tgtEl>
-                                        <p:attrNameLst>
-                                          <p:attrName>style.visibility</p:attrName>
-                                        </p:attrNameLst>
-                                      </p:cBhvr>
-                                      <p:to>
-                                        <p:strVal val="visible"/>
-                                      </p:to>
-                                    </p:set>
-                                  </p:childTnLst>
-                                </p:cTn>
-                              </p:par>
-                            </p:childTnLst>
-                          </p:cTn>
-                        </p:par>
-                      </p:childTnLst>
-                    </p:cTn>
-                  </p:par>
-                  <p:par>
-                    <p:cTn id="39" fill="hold">
-                      <p:stCondLst>
-                        <p:cond delay="indefinite"/>
-                      </p:stCondLst>
-                      <p:childTnLst>
-                        <p:par>
-                          <p:cTn id="40" fill="hold">
-                            <p:stCondLst>
-                              <p:cond delay="0"/>
-                            </p:stCondLst>
-                            <p:childTnLst>
-                              <p:par>
-                                <p:cTn id="41" presetID="1" presetClass="entr" presetSubtype="0" fill="hold" grpId="0" nodeType="clickEffect">
-                                  <p:stCondLst>
-                                    <p:cond delay="0"/>
-                                  </p:stCondLst>
-                                  <p:childTnLst>
-                                    <p:set>
-                                      <p:cBhvr>
-                                        <p:cTn id="42" dur="1" fill="hold">
-                                          <p:stCondLst>
-                                            <p:cond delay="0"/>
-                                          </p:stCondLst>
-                                        </p:cTn>
-                                        <p:tgtEl>
-                                          <p:spTgt spid="7">
-                                            <p:txEl>
-                                              <p:pRg st="1" end="1"/>
-                                            </p:txEl>
-                                          </p:spTgt>
-                                        </p:tgtEl>
-                                        <p:attrNameLst>
-                                          <p:attrName>style.visibility</p:attrName>
-                                        </p:attrNameLst>
-                                      </p:cBhvr>
-                                      <p:to>
-                                        <p:strVal val="visible"/>
-                                      </p:to>
-                                    </p:set>
-                                  </p:childTnLst>
-                                </p:cTn>
-                              </p:par>
-                            </p:childTnLst>
-                          </p:cTn>
-                        </p:par>
-                      </p:childTnLst>
-                    </p:cTn>
-                  </p:par>
-                  <p:par>
-                    <p:cTn id="43" fill="hold">
-                      <p:stCondLst>
-                        <p:cond delay="indefinite"/>
-                      </p:stCondLst>
-                      <p:childTnLst>
-                        <p:par>
-                          <p:cTn id="44" fill="hold">
-                            <p:stCondLst>
-                              <p:cond delay="0"/>
-                            </p:stCondLst>
-                            <p:childTnLst>
-                              <p:par>
-                                <p:cTn id="45" presetID="1" presetClass="entr" presetSubtype="0" fill="hold" grpId="0" nodeType="clickEffect">
-                                  <p:stCondLst>
-                                    <p:cond delay="0"/>
-                                  </p:stCondLst>
-                                  <p:childTnLst>
-                                    <p:set>
-                                      <p:cBhvr>
-                                        <p:cTn id="46" dur="1" fill="hold">
-                                          <p:stCondLst>
-                                            <p:cond delay="0"/>
-                                          </p:stCondLst>
-                                        </p:cTn>
-                                        <p:tgtEl>
-                                          <p:spTgt spid="7">
-                                            <p:txEl>
-                                              <p:pRg st="2" end="2"/>
-                                            </p:txEl>
-                                          </p:spTgt>
-                                        </p:tgtEl>
-                                        <p:attrNameLst>
-                                          <p:attrName>style.visibility</p:attrName>
-                                        </p:attrNameLst>
-                                      </p:cBhvr>
-                                      <p:to>
-                                        <p:strVal val="visible"/>
-                                      </p:to>
-                                    </p:set>
-                                  </p:childTnLst>
-                                </p:cTn>
-                              </p:par>
-                            </p:childTnLst>
-                          </p:cTn>
-                        </p:par>
-                      </p:childTnLst>
-                    </p:cTn>
-                  </p:par>
-                  <p:par>
-                    <p:cTn id="47" fill="hold">
-                      <p:stCondLst>
-                        <p:cond delay="indefinite"/>
-                      </p:stCondLst>
-                      <p:childTnLst>
-                        <p:par>
-                          <p:cTn id="48" fill="hold">
-                            <p:stCondLst>
-                              <p:cond delay="0"/>
-                            </p:stCondLst>
-                            <p:childTnLst>
-                              <p:par>
-                                <p:cTn id="49" presetID="1" presetClass="entr" presetSubtype="0" fill="hold" grpId="0" nodeType="clickEffect">
-                                  <p:stCondLst>
-                                    <p:cond delay="0"/>
-                                  </p:stCondLst>
-                                  <p:childTnLst>
-                                    <p:set>
-                                      <p:cBhvr>
-                                        <p:cTn id="50" dur="1" fill="hold">
-                                          <p:stCondLst>
-                                            <p:cond delay="0"/>
-                                          </p:stCondLst>
-                                        </p:cTn>
-                                        <p:tgtEl>
-                                          <p:spTgt spid="7">
-                                            <p:txEl>
-                                              <p:pRg st="3" end="3"/>
-                                            </p:txEl>
-                                          </p:spTgt>
-                                        </p:tgtEl>
-                                        <p:attrNameLst>
-                                          <p:attrName>style.visibility</p:attrName>
-                                        </p:attrNameLst>
-                                      </p:cBhvr>
-                                      <p:to>
-                                        <p:strVal val="visible"/>
-                                      </p:to>
-                                    </p:set>
-                                  </p:childTnLst>
-                                </p:cTn>
-                              </p:par>
-                            </p:childTnLst>
-                          </p:cTn>
-                        </p:par>
-                      </p:childTnLst>
-                    </p:cTn>
-                  </p:par>
-                </p:childTnLst>
-              </p:cTn>
-              <p:prevCondLst>
-                <p:cond evt="onPrev" delay="0">
-                  <p:tgtEl>
-                    <p:sldTgt/>
-                  </p:tgtEl>
-                </p:cond>
-              </p:prevCondLst>
-              <p:nextCondLst>
-                <p:cond evt="onNext" delay="0">
-                  <p:tgtEl>
-                    <p:sldTgt/>
-                  </p:tgtEl>
-                </p:cond>
-              </p:nextCondLst>
-            </p:seq>
-          </p:childTnLst>
-        </p:cTn>
-      </p:par>
-    </p:tnLst>
-    <p:bldLst>
-      <p:bldP spid="6" grpId="0" build="p"/>
-      <p:bldP spid="7" grpId="0" build="p"/>
     </p:bldLst>
   </p:timing>
 </p:sld>

</xml_diff>